<commit_message>
Add v10 Word report + expand OSM-ACD coverage to 9 of 11 stands
OSM-ACD driver: filter trees with DBH < 0.5 in or > 40 in. Seedling and
unrealistic-outlier trees were causing OSM init to reject 5 stands.
Cardinal job 11091396 now completes 9 of 11 stands (was 6 of 11).

Year-100 OSM-ACD now covers 5 of 6 populated cells (was 4 of 6):
- Cedar / C+D: BA 249, Cords 41.5 (new)
- Hardwood / C+D: BA 174 (was 172, n=2 now)
- Mixedwood / C+D: BA 183
- Commercial SW / A+B: BA 222
- Commercial SW / C+D: BA 199

Only Hardwood A+B still uncovered (H3B-N max DBH 54.5 in filtered out;
H3C-N still fails — under investigation).

Companion Word report v10 added: SILC_4Model_Benchmark_Report_v10.docx
brings the report current with the 4-model year-100 comparison, the cords/ac
table, and the refined input parameters table.
</commit_message>
<xml_diff>
--- a/calibration/output/comparisons_overstory/silc_cfi/SILC_4Model_Benchmark_v10_Weiskittel.pptx
+++ b/calibration/output/comparisons_overstory/silc_cfi/SILC_4Model_Benchmark_v10_Weiskittel.pptx
@@ -17457,7 +17457,7 @@
                           <a:ea typeface="Aptos" pitchFamily="34" charset="-122"/>
                           <a:cs typeface="Aptos" pitchFamily="34" charset="-120"/>
                         </a:rPr>
-                        <a:t>n/a</a:t>
+                        <a:t>249</a:t>
                       </a:r>
                       <a:endParaRPr lang="en-US" sz="1100" dirty="0">
                         <a:latin typeface="Aptos" charset="0"/>
@@ -17587,7 +17587,7 @@
                           <a:ea typeface="Aptos" pitchFamily="34" charset="-122"/>
                           <a:cs typeface="Aptos" pitchFamily="34" charset="-120"/>
                         </a:rPr>
-                        <a:t>n/a</a:t>
+                        <a:t>41.5</a:t>
                       </a:r>
                       <a:endParaRPr lang="en-US" sz="1100" dirty="0">
                         <a:latin typeface="Aptos" charset="0"/>
@@ -18631,7 +18631,7 @@
                           <a:ea typeface="Aptos" pitchFamily="34" charset="-122"/>
                           <a:cs typeface="Aptos" pitchFamily="34" charset="-120"/>
                         </a:rPr>
-                        <a:t>172</a:t>
+                        <a:t>174</a:t>
                       </a:r>
                       <a:endParaRPr lang="en-US" sz="1100" dirty="0">
                         <a:latin typeface="Aptos" charset="0"/>
@@ -18761,7 +18761,7 @@
                           <a:ea typeface="Aptos" pitchFamily="34" charset="-122"/>
                           <a:cs typeface="Aptos" pitchFamily="34" charset="-120"/>
                         </a:rPr>
-                        <a:t>31.7</a:t>
+                        <a:t>32.4</a:t>
                       </a:r>
                       <a:endParaRPr lang="en-US" sz="1100" dirty="0">
                         <a:latin typeface="Aptos" charset="0"/>
@@ -19808,7 +19808,7 @@
                           <a:ea typeface="Aptos" pitchFamily="34" charset="-122"/>
                           <a:cs typeface="Aptos" pitchFamily="34" charset="-120"/>
                         </a:rPr>
-                        <a:t>184</a:t>
+                        <a:t>183</a:t>
                       </a:r>
                       <a:endParaRPr lang="en-US" sz="1100" dirty="0">
                         <a:latin typeface="Aptos" charset="0"/>
@@ -19938,7 +19938,7 @@
                           <a:ea typeface="Aptos" pitchFamily="34" charset="-122"/>
                           <a:cs typeface="Aptos" pitchFamily="34" charset="-120"/>
                         </a:rPr>
-                        <a:t>34.4</a:t>
+                        <a:t>34.6</a:t>
                       </a:r>
                       <a:endParaRPr lang="en-US" sz="1100" dirty="0">
                         <a:latin typeface="Aptos" charset="0"/>
@@ -20395,7 +20395,7 @@
                           <a:ea typeface="Aptos" pitchFamily="34" charset="-122"/>
                           <a:cs typeface="Aptos" pitchFamily="34" charset="-120"/>
                         </a:rPr>
-                        <a:t>221</a:t>
+                        <a:t>222</a:t>
                       </a:r>
                       <a:endParaRPr lang="en-US" sz="1100" dirty="0">
                         <a:latin typeface="Aptos" charset="0"/>
@@ -20525,7 +20525,7 @@
                           <a:ea typeface="Aptos" pitchFamily="34" charset="-122"/>
                           <a:cs typeface="Aptos" pitchFamily="34" charset="-120"/>
                         </a:rPr>
-                        <a:t>39.9</a:t>
+                        <a:t>40.0</a:t>
                       </a:r>
                       <a:endParaRPr lang="en-US" sz="1100" dirty="0">
                         <a:latin typeface="Aptos" charset="0"/>
@@ -20982,7 +20982,7 @@
                           <a:ea typeface="Aptos" pitchFamily="34" charset="-122"/>
                           <a:cs typeface="Aptos" pitchFamily="34" charset="-120"/>
                         </a:rPr>
-                        <a:t>200</a:t>
+                        <a:t>199</a:t>
                       </a:r>
                       <a:endParaRPr lang="en-US" sz="1100" dirty="0">
                         <a:latin typeface="Aptos" charset="0"/>
@@ -21112,7 +21112,7 @@
                           <a:ea typeface="Aptos" pitchFamily="34" charset="-122"/>
                           <a:cs typeface="Aptos" pitchFamily="34" charset="-120"/>
                         </a:rPr>
-                        <a:t>36.5</a:t>
+                        <a:t>36.2</a:t>
                       </a:r>
                       <a:endParaRPr lang="en-US" sz="1100" dirty="0">
                         <a:latin typeface="Aptos" charset="0"/>
@@ -21788,7 +21788,7 @@
                 <a:ea typeface="Aptos" pitchFamily="34" charset="-122"/>
                 <a:cs typeface="Aptos" pitchFamily="34" charset="-120"/>
               </a:rPr>
-              <a:t>Year-100 (2123) BA in ft^2/ac, Cords/ac. AGM=AcadianGY 12.3.9; FVS-NE job 11078908; OSM-ACD job 11080104 (4 of 6 cells; 5 stands failed OSM init)</a:t>
+              <a:t>Year-100 (2123) BA in ft^2/ac, Cords/ac. AGM=AcadianGY 12.3.9; FVS-NE job 11078908; OSM-ACD job 11091396 (5 of 6 cells; H3B-N + H3C-N still failing — Hardwood A+B uncovered)</a:t>
             </a:r>
             <a:endParaRPr lang="en-US" sz="1000" dirty="0"/>
           </a:p>
@@ -21852,7 +21852,7 @@
                 <a:ea typeface="Aptos" pitchFamily="34" charset="-122"/>
                 <a:cs typeface="Aptos" pitchFamily="34" charset="-120"/>
               </a:rPr>
-              <a:t>AGM MORTCAL anchors low; OSM-ACD + FVS-NE cal cluster around 170-220 BA</a:t>
+              <a:t>AGM MORTCAL anchors low; OSM-ACD + FVS-NE cal cluster around 170-250 BA</a:t>
             </a:r>
             <a:endParaRPr lang="en-US" sz="2200" dirty="0"/>
           </a:p>

</xml_diff>